<commit_message>
Created german CPA instructions
</commit_message>
<xml_diff>
--- a/docs/aau.cnap.lnp.cogniPain2.protocol.v1/CPAInstructions_DE.pptx
+++ b/docs/aau.cnap.lnp.cogniPain2.protocol.v1/CPAInstructions_DE.pptx
@@ -200,7 +200,7 @@
           <a:p>
             <a:fld id="{9597641E-1FEC-4D17-ABE5-FD3DD377A8DB}" type="datetimeFigureOut">
               <a:rPr lang="en-DK" smtClean="0"/>
-              <a:t>10/11/2024</a:t>
+              <a:t>26/06/2026</a:t>
             </a:fld>
             <a:endParaRPr lang="en-DK"/>
           </a:p>
@@ -1169,7 +1169,7 @@
           <a:p>
             <a:fld id="{FD945BFA-2589-44DD-9174-8BD10EC1EAAD}" type="datetimeFigureOut">
               <a:rPr lang="en-DK" smtClean="0"/>
-              <a:t>10/11/2024</a:t>
+              <a:t>26/06/2026</a:t>
             </a:fld>
             <a:endParaRPr lang="en-DK"/>
           </a:p>
@@ -1369,7 +1369,7 @@
           <a:p>
             <a:fld id="{FD945BFA-2589-44DD-9174-8BD10EC1EAAD}" type="datetimeFigureOut">
               <a:rPr lang="en-DK" smtClean="0"/>
-              <a:t>10/11/2024</a:t>
+              <a:t>26/06/2026</a:t>
             </a:fld>
             <a:endParaRPr lang="en-DK"/>
           </a:p>
@@ -1579,7 +1579,7 @@
           <a:p>
             <a:fld id="{FD945BFA-2589-44DD-9174-8BD10EC1EAAD}" type="datetimeFigureOut">
               <a:rPr lang="en-DK" smtClean="0"/>
-              <a:t>10/11/2024</a:t>
+              <a:t>26/06/2026</a:t>
             </a:fld>
             <a:endParaRPr lang="en-DK"/>
           </a:p>
@@ -1779,7 +1779,7 @@
           <a:p>
             <a:fld id="{FD945BFA-2589-44DD-9174-8BD10EC1EAAD}" type="datetimeFigureOut">
               <a:rPr lang="en-DK" smtClean="0"/>
-              <a:t>10/11/2024</a:t>
+              <a:t>26/06/2026</a:t>
             </a:fld>
             <a:endParaRPr lang="en-DK"/>
           </a:p>
@@ -2055,7 +2055,7 @@
           <a:p>
             <a:fld id="{FD945BFA-2589-44DD-9174-8BD10EC1EAAD}" type="datetimeFigureOut">
               <a:rPr lang="en-DK" smtClean="0"/>
-              <a:t>10/11/2024</a:t>
+              <a:t>26/06/2026</a:t>
             </a:fld>
             <a:endParaRPr lang="en-DK"/>
           </a:p>
@@ -2323,7 +2323,7 @@
           <a:p>
             <a:fld id="{FD945BFA-2589-44DD-9174-8BD10EC1EAAD}" type="datetimeFigureOut">
               <a:rPr lang="en-DK" smtClean="0"/>
-              <a:t>10/11/2024</a:t>
+              <a:t>26/06/2026</a:t>
             </a:fld>
             <a:endParaRPr lang="en-DK"/>
           </a:p>
@@ -2738,7 +2738,7 @@
           <a:p>
             <a:fld id="{FD945BFA-2589-44DD-9174-8BD10EC1EAAD}" type="datetimeFigureOut">
               <a:rPr lang="en-DK" smtClean="0"/>
-              <a:t>10/11/2024</a:t>
+              <a:t>26/06/2026</a:t>
             </a:fld>
             <a:endParaRPr lang="en-DK"/>
           </a:p>
@@ -2880,7 +2880,7 @@
           <a:p>
             <a:fld id="{FD945BFA-2589-44DD-9174-8BD10EC1EAAD}" type="datetimeFigureOut">
               <a:rPr lang="en-DK" smtClean="0"/>
-              <a:t>10/11/2024</a:t>
+              <a:t>26/06/2026</a:t>
             </a:fld>
             <a:endParaRPr lang="en-DK"/>
           </a:p>
@@ -2993,7 +2993,7 @@
           <a:p>
             <a:fld id="{FD945BFA-2589-44DD-9174-8BD10EC1EAAD}" type="datetimeFigureOut">
               <a:rPr lang="en-DK" smtClean="0"/>
-              <a:t>10/11/2024</a:t>
+              <a:t>26/06/2026</a:t>
             </a:fld>
             <a:endParaRPr lang="en-DK"/>
           </a:p>
@@ -3306,7 +3306,7 @@
           <a:p>
             <a:fld id="{FD945BFA-2589-44DD-9174-8BD10EC1EAAD}" type="datetimeFigureOut">
               <a:rPr lang="en-DK" smtClean="0"/>
-              <a:t>10/11/2024</a:t>
+              <a:t>26/06/2026</a:t>
             </a:fld>
             <a:endParaRPr lang="en-DK"/>
           </a:p>
@@ -3595,7 +3595,7 @@
           <a:p>
             <a:fld id="{FD945BFA-2589-44DD-9174-8BD10EC1EAAD}" type="datetimeFigureOut">
               <a:rPr lang="en-DK" smtClean="0"/>
-              <a:t>10/11/2024</a:t>
+              <a:t>26/06/2026</a:t>
             </a:fld>
             <a:endParaRPr lang="en-DK"/>
           </a:p>
@@ -3838,7 +3838,7 @@
           <a:p>
             <a:fld id="{FD945BFA-2589-44DD-9174-8BD10EC1EAAD}" type="datetimeFigureOut">
               <a:rPr lang="en-DK" smtClean="0"/>
-              <a:t>10/11/2024</a:t>
+              <a:t>26/06/2026</a:t>
             </a:fld>
             <a:endParaRPr lang="en-DK"/>
           </a:p>
@@ -4270,7 +4270,7 @@
         <p:spPr>
           <a:xfrm>
             <a:off x="0" y="1"/>
-            <a:ext cx="12192000" cy="5847435"/>
+            <a:ext cx="12192000" cy="6374374"/>
           </a:xfrm>
           <a:prstGeom prst="rect">
             <a:avLst/>
@@ -4292,13 +4292,31 @@
               </a:spcAft>
             </a:pPr>
             <a:r>
+              <a:rPr lang="en-GB" sz="4400" b="1" kern="100" dirty="0" err="1">
+                <a:effectLst/>
+                <a:latin typeface="Calibri" panose="020F0502020204030204" pitchFamily="34" charset="0"/>
+                <a:ea typeface="Times New Roman" panose="02020603050405020304" pitchFamily="18" charset="0"/>
+                <a:cs typeface="Times New Roman" panose="02020603050405020304" pitchFamily="18" charset="0"/>
+              </a:rPr>
+              <a:t>Schmerzerkennung</a:t>
+            </a:r>
+            <a:r>
               <a:rPr lang="en-GB" sz="4400" b="1" kern="100" dirty="0">
                 <a:effectLst/>
                 <a:latin typeface="Calibri" panose="020F0502020204030204" pitchFamily="34" charset="0"/>
                 <a:ea typeface="Times New Roman" panose="02020603050405020304" pitchFamily="18" charset="0"/>
                 <a:cs typeface="Times New Roman" panose="02020603050405020304" pitchFamily="18" charset="0"/>
               </a:rPr>
-              <a:t>Pain Detection and Pain Tolerance Thresholds</a:t>
+              <a:t> und </a:t>
+            </a:r>
+            <a:r>
+              <a:rPr lang="en-GB" sz="4400" b="1" kern="100" dirty="0" err="1">
+                <a:effectLst/>
+                <a:latin typeface="Calibri" panose="020F0502020204030204" pitchFamily="34" charset="0"/>
+                <a:ea typeface="Times New Roman" panose="02020603050405020304" pitchFamily="18" charset="0"/>
+                <a:cs typeface="Times New Roman" panose="02020603050405020304" pitchFamily="18" charset="0"/>
+              </a:rPr>
+              <a:t>Schmerztoleranzschwellen</a:t>
             </a:r>
             <a:endParaRPr lang="en-DK" sz="1400" kern="100" dirty="0">
               <a:effectLst/>
@@ -4317,13 +4335,22 @@
               </a:spcAft>
             </a:pPr>
             <a:r>
+              <a:rPr lang="en-GB" sz="4400" kern="100" dirty="0" err="1">
+                <a:effectLst/>
+                <a:latin typeface="Calibri" panose="020F0502020204030204" pitchFamily="34" charset="0"/>
+                <a:ea typeface="Times New Roman" panose="02020603050405020304" pitchFamily="18" charset="0"/>
+                <a:cs typeface="Times New Roman" panose="02020603050405020304" pitchFamily="18" charset="0"/>
+              </a:rPr>
+              <a:t>Dominantes</a:t>
+            </a:r>
+            <a:r>
               <a:rPr lang="en-GB" sz="4400" kern="100" dirty="0">
                 <a:effectLst/>
                 <a:latin typeface="Calibri" panose="020F0502020204030204" pitchFamily="34" charset="0"/>
                 <a:ea typeface="Times New Roman" panose="02020603050405020304" pitchFamily="18" charset="0"/>
                 <a:cs typeface="Times New Roman" panose="02020603050405020304" pitchFamily="18" charset="0"/>
               </a:rPr>
-              <a:t>Dominant Leg</a:t>
+              <a:t> Bein</a:t>
             </a:r>
             <a:endParaRPr lang="en-DK" sz="1400" kern="100" dirty="0">
               <a:effectLst/>
@@ -4367,13 +4394,31 @@
               </a:spcAft>
             </a:pPr>
             <a:r>
+              <a:rPr lang="en-GB" sz="3200" b="1" kern="100" dirty="0" err="1">
+                <a:effectLst/>
+                <a:latin typeface="Calibri" panose="020F0502020204030204" pitchFamily="34" charset="0"/>
+                <a:ea typeface="Times New Roman" panose="02020603050405020304" pitchFamily="18" charset="0"/>
+                <a:cs typeface="Times New Roman" panose="02020603050405020304" pitchFamily="18" charset="0"/>
+              </a:rPr>
+              <a:t>Anweisungen</a:t>
+            </a:r>
+            <a:r>
               <a:rPr lang="en-GB" sz="3200" b="1" kern="100" dirty="0">
                 <a:effectLst/>
                 <a:latin typeface="Calibri" panose="020F0502020204030204" pitchFamily="34" charset="0"/>
                 <a:ea typeface="Times New Roman" panose="02020603050405020304" pitchFamily="18" charset="0"/>
                 <a:cs typeface="Times New Roman" panose="02020603050405020304" pitchFamily="18" charset="0"/>
               </a:rPr>
-              <a:t>Instructions to the subject</a:t>
+              <a:t> für den </a:t>
+            </a:r>
+            <a:r>
+              <a:rPr lang="en-GB" sz="3200" b="1" kern="100" dirty="0" err="1">
+                <a:effectLst/>
+                <a:latin typeface="Calibri" panose="020F0502020204030204" pitchFamily="34" charset="0"/>
+                <a:ea typeface="Times New Roman" panose="02020603050405020304" pitchFamily="18" charset="0"/>
+                <a:cs typeface="Times New Roman" panose="02020603050405020304" pitchFamily="18" charset="0"/>
+              </a:rPr>
+              <a:t>Teilnehmer</a:t>
             </a:r>
             <a:endParaRPr lang="en-DK" sz="1400" kern="100" dirty="0">
               <a:effectLst/>
@@ -4392,49 +4437,13 @@
               </a:spcAft>
             </a:pPr>
             <a:r>
-              <a:rPr lang="en-GB" sz="3200" kern="100" dirty="0">
+              <a:rPr lang="de-DE" sz="3200" kern="100" dirty="0">
                 <a:effectLst/>
                 <a:latin typeface="Calibri" panose="020F0502020204030204" pitchFamily="34" charset="0"/>
                 <a:ea typeface="Times New Roman" panose="02020603050405020304" pitchFamily="18" charset="0"/>
                 <a:cs typeface="Times New Roman" panose="02020603050405020304" pitchFamily="18" charset="0"/>
               </a:rPr>
-              <a:t>In this test, the pressure on the cuff on your dominant leg will gradually increase. I would like you to rate the pressure sensation with the scale in your hand. The scale goes from </a:t>
-            </a:r>
-            <a:r>
-              <a:rPr lang="en-GB" sz="3200" b="1" kern="100" dirty="0">
-                <a:effectLst/>
-                <a:latin typeface="Calibri" panose="020F0502020204030204" pitchFamily="34" charset="0"/>
-                <a:ea typeface="Times New Roman" panose="02020603050405020304" pitchFamily="18" charset="0"/>
-                <a:cs typeface="Times New Roman" panose="02020603050405020304" pitchFamily="18" charset="0"/>
-              </a:rPr>
-              <a:t>No Pain</a:t>
-            </a:r>
-            <a:r>
-              <a:rPr lang="en-GB" sz="3200" kern="100" dirty="0">
-                <a:effectLst/>
-                <a:latin typeface="Calibri" panose="020F0502020204030204" pitchFamily="34" charset="0"/>
-                <a:ea typeface="Times New Roman" panose="02020603050405020304" pitchFamily="18" charset="0"/>
-                <a:cs typeface="Times New Roman" panose="02020603050405020304" pitchFamily="18" charset="0"/>
-              </a:rPr>
-              <a:t> to </a:t>
-            </a:r>
-            <a:r>
-              <a:rPr lang="en-GB" sz="3200" b="1" kern="100" dirty="0">
-                <a:effectLst/>
-                <a:latin typeface="Calibri" panose="020F0502020204030204" pitchFamily="34" charset="0"/>
-                <a:ea typeface="Times New Roman" panose="02020603050405020304" pitchFamily="18" charset="0"/>
-                <a:cs typeface="Times New Roman" panose="02020603050405020304" pitchFamily="18" charset="0"/>
-              </a:rPr>
-              <a:t>Maximal Pain</a:t>
-            </a:r>
-            <a:r>
-              <a:rPr lang="en-GB" sz="3200" kern="100" dirty="0">
-                <a:effectLst/>
-                <a:latin typeface="Calibri" panose="020F0502020204030204" pitchFamily="34" charset="0"/>
-                <a:ea typeface="Times New Roman" panose="02020603050405020304" pitchFamily="18" charset="0"/>
-                <a:cs typeface="Times New Roman" panose="02020603050405020304" pitchFamily="18" charset="0"/>
-              </a:rPr>
-              <a:t>. When you rate the pain, it is important that you start rating the moment you feel the slightest hint of pain. The Maximal Pain is the worst pain you can endure and when you reach this level the pressure will automatically stop.</a:t>
+              <a:t>Bei diesem Test wird der Druck der Manschette an Ihrem dominanten Bein allmählich erhöht. Bitte bewerten Sie das Druckempfinden mithilfe der Skala in Ihrer Hand. Die Skala reicht von „Kein Schmerz“ bis „Maximaler Schmerz“. Wichtig ist, dass Sie mit der Bewertung beginnen, sobald Sie auch nur den geringsten Schmerz verspüren. Der maximale Schmerz ist der stärkste erträgliche Schmerz. Sobald Sie diesen Wert erreichen, wird der Druck automatisch gestoppt.</a:t>
             </a:r>
             <a:endParaRPr lang="en-DK" sz="1400" kern="100" dirty="0">
               <a:effectLst/>
@@ -4518,16 +4527,30 @@
               </a:spcAft>
             </a:pPr>
             <a:r>
-              <a:rPr lang="en-GB" sz="4400" b="1" kern="100" dirty="0">
-                <a:effectLst/>
+              <a:rPr lang="en-GB" sz="4400" b="1" kern="100" dirty="0" err="1">
                 <a:latin typeface="Calibri" panose="020F0502020204030204" pitchFamily="34" charset="0"/>
                 <a:ea typeface="Times New Roman" panose="02020603050405020304" pitchFamily="18" charset="0"/>
                 <a:cs typeface="Times New Roman" panose="02020603050405020304" pitchFamily="18" charset="0"/>
               </a:rPr>
-              <a:t>Pain Detection and Pain Tolerance Thresholds</a:t>
+              <a:t>Schmerzerkennung</a:t>
+            </a:r>
+            <a:r>
+              <a:rPr lang="en-GB" sz="4400" b="1" kern="100" dirty="0">
+                <a:latin typeface="Calibri" panose="020F0502020204030204" pitchFamily="34" charset="0"/>
+                <a:ea typeface="Times New Roman" panose="02020603050405020304" pitchFamily="18" charset="0"/>
+                <a:cs typeface="Times New Roman" panose="02020603050405020304" pitchFamily="18" charset="0"/>
+              </a:rPr>
+              <a:t> und </a:t>
+            </a:r>
+            <a:r>
+              <a:rPr lang="en-GB" sz="4400" b="1" kern="100" dirty="0" err="1">
+                <a:latin typeface="Calibri" panose="020F0502020204030204" pitchFamily="34" charset="0"/>
+                <a:ea typeface="Times New Roman" panose="02020603050405020304" pitchFamily="18" charset="0"/>
+                <a:cs typeface="Times New Roman" panose="02020603050405020304" pitchFamily="18" charset="0"/>
+              </a:rPr>
+              <a:t>Schmerztoleranzschwellen</a:t>
             </a:r>
             <a:endParaRPr lang="en-DK" sz="1400" kern="100" dirty="0">
-              <a:effectLst/>
               <a:latin typeface="Calibri" panose="020F0502020204030204" pitchFamily="34" charset="0"/>
               <a:ea typeface="Times New Roman" panose="02020603050405020304" pitchFamily="18" charset="0"/>
               <a:cs typeface="Times New Roman" panose="02020603050405020304" pitchFamily="18" charset="0"/>
@@ -4549,7 +4572,25 @@
                 <a:ea typeface="Times New Roman" panose="02020603050405020304" pitchFamily="18" charset="0"/>
                 <a:cs typeface="Times New Roman" panose="02020603050405020304" pitchFamily="18" charset="0"/>
               </a:rPr>
-              <a:t>Non-Dominant Leg</a:t>
+              <a:t>Nicht-</a:t>
+            </a:r>
+            <a:r>
+              <a:rPr lang="en-GB" sz="4400" kern="100" dirty="0" err="1">
+                <a:effectLst/>
+                <a:latin typeface="Calibri" panose="020F0502020204030204" pitchFamily="34" charset="0"/>
+                <a:ea typeface="Times New Roman" panose="02020603050405020304" pitchFamily="18" charset="0"/>
+                <a:cs typeface="Times New Roman" panose="02020603050405020304" pitchFamily="18" charset="0"/>
+              </a:rPr>
+              <a:t>dominantes</a:t>
+            </a:r>
+            <a:r>
+              <a:rPr lang="en-GB" sz="4400" kern="100" dirty="0">
+                <a:effectLst/>
+                <a:latin typeface="Calibri" panose="020F0502020204030204" pitchFamily="34" charset="0"/>
+                <a:ea typeface="Times New Roman" panose="02020603050405020304" pitchFamily="18" charset="0"/>
+                <a:cs typeface="Times New Roman" panose="02020603050405020304" pitchFamily="18" charset="0"/>
+              </a:rPr>
+              <a:t> Bein</a:t>
             </a:r>
             <a:endParaRPr lang="en-DK" sz="1400" kern="100" dirty="0">
               <a:effectLst/>
@@ -4593,13 +4634,28 @@
               </a:spcAft>
             </a:pPr>
             <a:r>
-              <a:rPr lang="en-GB" sz="3200" b="1" kern="100" dirty="0">
-                <a:effectLst/>
+              <a:rPr lang="en-GB" sz="3200" b="1" kern="100" dirty="0" err="1">
                 <a:latin typeface="Calibri" panose="020F0502020204030204" pitchFamily="34" charset="0"/>
                 <a:ea typeface="Times New Roman" panose="02020603050405020304" pitchFamily="18" charset="0"/>
                 <a:cs typeface="Times New Roman" panose="02020603050405020304" pitchFamily="18" charset="0"/>
               </a:rPr>
-              <a:t>Instructions to the subject</a:t>
+              <a:t>Anweisungen</a:t>
+            </a:r>
+            <a:r>
+              <a:rPr lang="en-GB" sz="3200" b="1" kern="100" dirty="0">
+                <a:latin typeface="Calibri" panose="020F0502020204030204" pitchFamily="34" charset="0"/>
+                <a:ea typeface="Times New Roman" panose="02020603050405020304" pitchFamily="18" charset="0"/>
+                <a:cs typeface="Times New Roman" panose="02020603050405020304" pitchFamily="18" charset="0"/>
+              </a:rPr>
+              <a:t> für den </a:t>
+            </a:r>
+            <a:r>
+              <a:rPr lang="en-GB" sz="3200" b="1" kern="100" dirty="0" err="1">
+                <a:latin typeface="Calibri" panose="020F0502020204030204" pitchFamily="34" charset="0"/>
+                <a:ea typeface="Times New Roman" panose="02020603050405020304" pitchFamily="18" charset="0"/>
+                <a:cs typeface="Times New Roman" panose="02020603050405020304" pitchFamily="18" charset="0"/>
+              </a:rPr>
+              <a:t>Teilnehmer</a:t>
             </a:r>
             <a:endParaRPr lang="en-DK" sz="1400" kern="100" dirty="0">
               <a:effectLst/>
@@ -4618,13 +4674,13 @@
               </a:spcAft>
             </a:pPr>
             <a:r>
-              <a:rPr lang="en-GB" sz="3200" kern="100" dirty="0">
+              <a:rPr lang="de-DE" sz="3200" kern="100" dirty="0">
                 <a:effectLst/>
                 <a:latin typeface="Calibri" panose="020F0502020204030204" pitchFamily="34" charset="0"/>
                 <a:ea typeface="Times New Roman" panose="02020603050405020304" pitchFamily="18" charset="0"/>
                 <a:cs typeface="Times New Roman" panose="02020603050405020304" pitchFamily="18" charset="0"/>
               </a:rPr>
-              <a:t>In this test, the pressure on the cuff on your non-dominant leg will gradually increase. I would like you to rate the pressure sensation with the scale in your hand. Please rate this pressure sensation in the same way as before.</a:t>
+              <a:t>Bei diesem Test wird der Druck der Manschette an Ihrem nicht-dominanten Bein schrittweise erhöht. Bitte bewerten Sie das Druckempfinden mithilfe der Skala in Ihrer Hand. Gehen Sie dabei bitte genauso vor wie zuvor.</a:t>
             </a:r>
             <a:endParaRPr lang="en-DK" sz="1400" kern="100" dirty="0">
               <a:effectLst/>
@@ -4686,7 +4742,7 @@
         <p:spPr>
           <a:xfrm>
             <a:off x="0" y="0"/>
-            <a:ext cx="12192000" cy="5547288"/>
+            <a:ext cx="12192000" cy="6074227"/>
           </a:xfrm>
           <a:prstGeom prst="rect">
             <a:avLst/>
@@ -4708,13 +4764,22 @@
               </a:spcAft>
             </a:pPr>
             <a:r>
+              <a:rPr lang="en-GB" sz="4400" b="1" kern="100" dirty="0" err="1">
+                <a:effectLst/>
+                <a:latin typeface="Calibri" panose="020F0502020204030204" pitchFamily="34" charset="0"/>
+                <a:ea typeface="Times New Roman" panose="02020603050405020304" pitchFamily="18" charset="0"/>
+                <a:cs typeface="Times New Roman" panose="02020603050405020304" pitchFamily="18" charset="0"/>
+              </a:rPr>
+              <a:t>Zeitliche</a:t>
+            </a:r>
+            <a:r>
               <a:rPr lang="en-GB" sz="4400" b="1" kern="100" dirty="0">
                 <a:effectLst/>
                 <a:latin typeface="Calibri" panose="020F0502020204030204" pitchFamily="34" charset="0"/>
                 <a:ea typeface="Times New Roman" panose="02020603050405020304" pitchFamily="18" charset="0"/>
                 <a:cs typeface="Times New Roman" panose="02020603050405020304" pitchFamily="18" charset="0"/>
               </a:rPr>
-              <a:t>Temporal Summation</a:t>
+              <a:t> Summation</a:t>
             </a:r>
             <a:endParaRPr lang="en-DK" sz="1400" kern="100" dirty="0">
               <a:effectLst/>
@@ -4758,13 +4823,31 @@
               </a:spcAft>
             </a:pPr>
             <a:r>
+              <a:rPr lang="en-GB" sz="3200" b="1" kern="100" dirty="0" err="1">
+                <a:effectLst/>
+                <a:latin typeface="Calibri" panose="020F0502020204030204" pitchFamily="34" charset="0"/>
+                <a:ea typeface="Times New Roman" panose="02020603050405020304" pitchFamily="18" charset="0"/>
+                <a:cs typeface="Times New Roman" panose="02020603050405020304" pitchFamily="18" charset="0"/>
+              </a:rPr>
+              <a:t>Anweisungen</a:t>
+            </a:r>
+            <a:r>
               <a:rPr lang="en-GB" sz="3200" b="1" kern="100" dirty="0">
                 <a:effectLst/>
                 <a:latin typeface="Calibri" panose="020F0502020204030204" pitchFamily="34" charset="0"/>
                 <a:ea typeface="Times New Roman" panose="02020603050405020304" pitchFamily="18" charset="0"/>
                 <a:cs typeface="Times New Roman" panose="02020603050405020304" pitchFamily="18" charset="0"/>
               </a:rPr>
-              <a:t>Instructions the subject</a:t>
+              <a:t> für den </a:t>
+            </a:r>
+            <a:r>
+              <a:rPr lang="en-GB" sz="3200" b="1" kern="100" dirty="0" err="1">
+                <a:effectLst/>
+                <a:latin typeface="Calibri" panose="020F0502020204030204" pitchFamily="34" charset="0"/>
+                <a:ea typeface="Times New Roman" panose="02020603050405020304" pitchFamily="18" charset="0"/>
+                <a:cs typeface="Times New Roman" panose="02020603050405020304" pitchFamily="18" charset="0"/>
+              </a:rPr>
+              <a:t>Teilnehmer</a:t>
             </a:r>
             <a:endParaRPr lang="en-DK" sz="1400" kern="100" dirty="0">
               <a:effectLst/>
@@ -4783,13 +4866,13 @@
               </a:spcAft>
             </a:pPr>
             <a:r>
-              <a:rPr lang="en-GB" sz="3200" kern="100" dirty="0">
+              <a:rPr lang="de-DE" sz="3200" kern="100" dirty="0">
                 <a:effectLst/>
                 <a:latin typeface="Calibri" panose="020F0502020204030204" pitchFamily="34" charset="0"/>
                 <a:ea typeface="Times New Roman" panose="02020603050405020304" pitchFamily="18" charset="0"/>
                 <a:cs typeface="Times New Roman" panose="02020603050405020304" pitchFamily="18" charset="0"/>
               </a:rPr>
-              <a:t>This is a new test that is a bit different from the ones before. In this test you will feel pressure squeezes one after another. For each squeeze rate the pressure sensation as quickly as possible with the rating scale in your hand. After you rated the sensation just leave the slider where it is until you feel the next squeeze. The squeezes comes fast and there is no right or wrong answer, just provide your immediate rating of the sensation as fast as possible.</a:t>
+              <a:t>Dies ist ein neuer Test, der sich etwas von den vorherigen unterscheidet. Sie spüren nacheinander verschiedene Druckreize. Bewerten Sie bei jedem Reiz die Empfindung so schnell wie möglich mithilfe der Skala in Ihrer Hand. Lassen Sie den Schieber nach der Bewertung einfach in seiner Position, bis Sie den nächsten Reiz spüren. Die Reize folgen schnell aufeinander, und es gibt keine richtige oder falsche Antwort. Geben Sie einfach Ihre unmittelbare Bewertung der Empfindung so schnell wie möglich an.</a:t>
             </a:r>
             <a:endParaRPr lang="en-DK" sz="1400" kern="100" dirty="0">
               <a:effectLst/>
@@ -4851,7 +4934,7 @@
         <p:spPr>
           <a:xfrm>
             <a:off x="0" y="0"/>
-            <a:ext cx="12192000" cy="6074227"/>
+            <a:ext cx="12192000" cy="6601166"/>
           </a:xfrm>
           <a:prstGeom prst="rect">
             <a:avLst/>
@@ -4873,13 +4956,31 @@
               </a:spcAft>
             </a:pPr>
             <a:r>
+              <a:rPr lang="en-GB" sz="4400" b="1" kern="100" dirty="0" err="1">
+                <a:effectLst/>
+                <a:latin typeface="Calibri" panose="020F0502020204030204" pitchFamily="34" charset="0"/>
+                <a:ea typeface="Times New Roman" panose="02020603050405020304" pitchFamily="18" charset="0"/>
+                <a:cs typeface="Times New Roman" panose="02020603050405020304" pitchFamily="18" charset="0"/>
+              </a:rPr>
+              <a:t>Konditionierte</a:t>
+            </a:r>
+            <a:r>
               <a:rPr lang="en-GB" sz="4400" b="1" kern="100" dirty="0">
                 <a:effectLst/>
                 <a:latin typeface="Calibri" panose="020F0502020204030204" pitchFamily="34" charset="0"/>
                 <a:ea typeface="Times New Roman" panose="02020603050405020304" pitchFamily="18" charset="0"/>
                 <a:cs typeface="Times New Roman" panose="02020603050405020304" pitchFamily="18" charset="0"/>
               </a:rPr>
-              <a:t>Conditioned Pain Modulation</a:t>
+              <a:t> </a:t>
+            </a:r>
+            <a:r>
+              <a:rPr lang="en-GB" sz="4400" b="1" kern="100" dirty="0" err="1">
+                <a:effectLst/>
+                <a:latin typeface="Calibri" panose="020F0502020204030204" pitchFamily="34" charset="0"/>
+                <a:ea typeface="Times New Roman" panose="02020603050405020304" pitchFamily="18" charset="0"/>
+                <a:cs typeface="Times New Roman" panose="02020603050405020304" pitchFamily="18" charset="0"/>
+              </a:rPr>
+              <a:t>Schmerzmodulation</a:t>
             </a:r>
             <a:endParaRPr lang="en-DK" sz="1400" kern="100" dirty="0">
               <a:effectLst/>
@@ -4923,13 +5024,31 @@
               </a:spcAft>
             </a:pPr>
             <a:r>
+              <a:rPr lang="en-GB" sz="3200" b="1" kern="100" dirty="0" err="1">
+                <a:effectLst/>
+                <a:latin typeface="Calibri" panose="020F0502020204030204" pitchFamily="34" charset="0"/>
+                <a:ea typeface="Times New Roman" panose="02020603050405020304" pitchFamily="18" charset="0"/>
+                <a:cs typeface="Times New Roman" panose="02020603050405020304" pitchFamily="18" charset="0"/>
+              </a:rPr>
+              <a:t>Anweisungen</a:t>
+            </a:r>
+            <a:r>
               <a:rPr lang="en-GB" sz="3200" b="1" kern="100" dirty="0">
                 <a:effectLst/>
                 <a:latin typeface="Calibri" panose="020F0502020204030204" pitchFamily="34" charset="0"/>
                 <a:ea typeface="Times New Roman" panose="02020603050405020304" pitchFamily="18" charset="0"/>
                 <a:cs typeface="Times New Roman" panose="02020603050405020304" pitchFamily="18" charset="0"/>
               </a:rPr>
-              <a:t>Instructions to the subject</a:t>
+              <a:t> für den </a:t>
+            </a:r>
+            <a:r>
+              <a:rPr lang="en-GB" sz="3200" b="1" kern="100" dirty="0" err="1">
+                <a:effectLst/>
+                <a:latin typeface="Calibri" panose="020F0502020204030204" pitchFamily="34" charset="0"/>
+                <a:ea typeface="Times New Roman" panose="02020603050405020304" pitchFamily="18" charset="0"/>
+                <a:cs typeface="Times New Roman" panose="02020603050405020304" pitchFamily="18" charset="0"/>
+              </a:rPr>
+              <a:t>Teilnehmer</a:t>
             </a:r>
             <a:endParaRPr lang="en-DK" sz="1400" kern="100" dirty="0">
               <a:effectLst/>
@@ -4948,49 +5067,13 @@
               </a:spcAft>
             </a:pPr>
             <a:r>
-              <a:rPr lang="en-GB" sz="3200" kern="100" dirty="0">
+              <a:rPr lang="de-DE" sz="3200" kern="100" dirty="0">
                 <a:effectLst/>
                 <a:latin typeface="Calibri" panose="020F0502020204030204" pitchFamily="34" charset="0"/>
                 <a:ea typeface="Times New Roman" panose="02020603050405020304" pitchFamily="18" charset="0"/>
                 <a:cs typeface="Times New Roman" panose="02020603050405020304" pitchFamily="18" charset="0"/>
               </a:rPr>
-              <a:t>In this test you will feel an intense painful pressure squeeze on your non-dominant leg while the pressure on the cuff on your dominant leg will gradually increase. I would like you to rate the pain you feel on the dominant leg only with the scale in your hand. The scale goes from </a:t>
-            </a:r>
-            <a:r>
-              <a:rPr lang="en-GB" sz="3200" b="1" kern="100" dirty="0">
-                <a:effectLst/>
-                <a:latin typeface="Calibri" panose="020F0502020204030204" pitchFamily="34" charset="0"/>
-                <a:ea typeface="Times New Roman" panose="02020603050405020304" pitchFamily="18" charset="0"/>
-                <a:cs typeface="Times New Roman" panose="02020603050405020304" pitchFamily="18" charset="0"/>
-              </a:rPr>
-              <a:t>No Pain</a:t>
-            </a:r>
-            <a:r>
-              <a:rPr lang="en-GB" sz="3200" kern="100" dirty="0">
-                <a:effectLst/>
-                <a:latin typeface="Calibri" panose="020F0502020204030204" pitchFamily="34" charset="0"/>
-                <a:ea typeface="Times New Roman" panose="02020603050405020304" pitchFamily="18" charset="0"/>
-                <a:cs typeface="Times New Roman" panose="02020603050405020304" pitchFamily="18" charset="0"/>
-              </a:rPr>
-              <a:t> to </a:t>
-            </a:r>
-            <a:r>
-              <a:rPr lang="en-GB" sz="3200" b="1" kern="100" dirty="0">
-                <a:effectLst/>
-                <a:latin typeface="Calibri" panose="020F0502020204030204" pitchFamily="34" charset="0"/>
-                <a:ea typeface="Times New Roman" panose="02020603050405020304" pitchFamily="18" charset="0"/>
-                <a:cs typeface="Times New Roman" panose="02020603050405020304" pitchFamily="18" charset="0"/>
-              </a:rPr>
-              <a:t>Maximal Pain</a:t>
-            </a:r>
-            <a:r>
-              <a:rPr lang="en-GB" sz="3200" kern="100" dirty="0">
-                <a:effectLst/>
-                <a:latin typeface="Calibri" panose="020F0502020204030204" pitchFamily="34" charset="0"/>
-                <a:ea typeface="Times New Roman" panose="02020603050405020304" pitchFamily="18" charset="0"/>
-                <a:cs typeface="Times New Roman" panose="02020603050405020304" pitchFamily="18" charset="0"/>
-              </a:rPr>
-              <a:t>. When you rate the pain, it is important that you start rating the moment you feel the slightest hint of pain. The Maximal Pain is the worst pain you can endure and when you reach this level the pressure will automatically stop.</a:t>
+              <a:t>Bei diesem Test spüren Sie einen intensiven, schmerzhaften Druck auf Ihr nicht-dominantes Bein, während der Druck auf die Manschette an Ihrem dominanten Bein allmählich zunimmt. Bitte bewerten Sie die Schmerzen, die Sie nur an Ihrem dominanten Bein empfinden, mithilfe der Skala in Ihrer Hand. Die Skala reicht von „Kein Schmerz“ bis „Maximaler Schmerz“. Wichtig ist, dass Sie mit der Bewertung beginnen, sobald Sie auch nur den geringsten Schmerz verspüren. Der maximale Schmerz ist der stärkste erträgliche Schmerz. Sobald Sie diesen Wert erreichen, wird der Druck automatisch gestoppt.</a:t>
             </a:r>
             <a:endParaRPr lang="en-DK" sz="1400" kern="100" dirty="0">
               <a:effectLst/>

</xml_diff>